<commit_message>
Update Asynchronous v Parallel
</commit_message>
<xml_diff>
--- a/5. Asynchronous vs Parallel Programming/AsyncVsParallel.pptx
+++ b/5. Asynchronous vs Parallel Programming/AsyncVsParallel.pptx
@@ -254,7 +254,7 @@
               <a:rPr lang="en-US" smtClean="0">
                 <a:latin typeface="Segoe UI" pitchFamily="34" charset="0"/>
               </a:rPr>
-              <a:t>9/7/26 11:52 AM</a:t>
+              <a:t>9/12/26 4:17 PM</a:t>
             </a:fld>
             <a:endParaRPr lang="en-US">
               <a:latin typeface="Segoe UI" pitchFamily="34" charset="0"/>
@@ -532,7 +532,7 @@
           <a:p>
             <a:fld id="{D18B56EA-E28F-4F92-9F16-7A6F2501B303}" type="datetime8">
               <a:rPr lang="en-US" smtClean="0"/>
-              <a:t>9/7/26 11:52 AM</a:t>
+              <a:t>9/12/26 4:17 PM</a:t>
             </a:fld>
             <a:endParaRPr lang="en-US"/>
           </a:p>
@@ -8418,7 +8418,7 @@
         <p:spPr>
           <a:xfrm>
             <a:off x="274320" y="1627632"/>
-            <a:ext cx="5303520" cy="2296013"/>
+            <a:ext cx="5303520" cy="2585323"/>
           </a:xfrm>
         </p:spPr>
         <p:txBody>
@@ -8433,7 +8433,21 @@
           <a:p>
             <a:r>
               <a:rPr lang="en-US" sz="2800" dirty="0"/>
-              <a:t>`new(1, 1)` makes it mutual exclusion</a:t>
+              <a:t>`new(1, 1)` </a:t>
+            </a:r>
+          </a:p>
+          <a:p>
+            <a:pPr lvl="1"/>
+            <a:r>
+              <a:rPr lang="en-US" sz="2000" dirty="0"/>
+              <a:t>Sets the initial thread count to 1</a:t>
+            </a:r>
+          </a:p>
+          <a:p>
+            <a:pPr lvl="1"/>
+            <a:r>
+              <a:rPr lang="en-US" sz="2000" dirty="0"/>
+              <a:t>Sets the maximum thread count to 1</a:t>
             </a:r>
           </a:p>
           <a:p>
@@ -8609,7 +8623,7 @@
             <a:pPr lvl="1"/>
             <a:r>
               <a:rPr lang="en-US" dirty="0"/>
-              <a:t>Waiting for the permit it already holds</a:t>
+              <a:t>Waiting for itself to finish the work it is waiting on</a:t>
             </a:r>
           </a:p>
         </p:txBody>
@@ -8717,8 +8731,8 @@
         </p:nvSpPr>
         <p:spPr>
           <a:xfrm>
-            <a:off x="274320" y="1627632"/>
-            <a:ext cx="5303520" cy="1908215"/>
+            <a:off x="274319" y="1627632"/>
+            <a:ext cx="10208623" cy="1520416"/>
           </a:xfrm>
         </p:spPr>
         <p:txBody>
@@ -8733,7 +8747,15 @@
           <a:p>
             <a:r>
               <a:rPr lang="en-US" sz="2800" dirty="0"/>
-              <a:t>Replaces `_field ??= Build()`</a:t>
+              <a:t>Replaces `_menu ??= </a:t>
+            </a:r>
+            <a:r>
+              <a:rPr lang="en-US" sz="2800" dirty="0" err="1"/>
+              <a:t>BuildMenu</a:t>
+            </a:r>
+            <a:r>
+              <a:rPr lang="en-US" sz="2800" dirty="0"/>
+              <a:t>()`</a:t>
             </a:r>
           </a:p>
           <a:p>
@@ -8754,14 +8776,15 @@
         </p:nvPicPr>
         <p:blipFill>
           <a:blip r:embed="rId3"/>
+          <a:srcRect l="7870" t="14183" r="8961" b="37529"/>
           <a:stretch>
             <a:fillRect/>
           </a:stretch>
         </p:blipFill>
         <p:spPr>
           <a:xfrm>
-            <a:off x="5577839" y="1676678"/>
-            <a:ext cx="6583680" cy="4373323"/>
+            <a:off x="6139541" y="4049487"/>
+            <a:ext cx="5475515" cy="2111828"/>
           </a:xfrm>
           <a:prstGeom prst="rect">
             <a:avLst/>
@@ -9294,14 +9317,14 @@
           <a:p>
             <a:r>
               <a:rPr lang="en-US" dirty="0"/>
-              <a:t>Allows code to execute on a background thread*</a:t>
+              <a:t>Allows code to execute on a background thread</a:t>
             </a:r>
           </a:p>
           <a:p>
             <a:pPr lvl="2"/>
             <a:r>
               <a:rPr lang="en-US" dirty="0"/>
-              <a:t>*By default, and only once it actually yields</a:t>
+              <a:t>By default, and only once it actually yields</a:t>
             </a:r>
           </a:p>
           <a:p>
@@ -9433,7 +9456,7 @@
         <p:spPr>
           <a:xfrm>
             <a:off x="274320" y="1627632"/>
-            <a:ext cx="11887200" cy="3527119"/>
+            <a:ext cx="11887200" cy="2376035"/>
           </a:xfrm>
         </p:spPr>
         <p:txBody>
@@ -9454,25 +9477,13 @@
           <a:p>
             <a:r>
               <a:rPr lang="en-US" dirty="0"/>
-              <a:t>Something running the entire time</a:t>
-            </a:r>
-          </a:p>
-          <a:p>
-            <a:r>
-              <a:rPr lang="en-US" dirty="0"/>
-              <a:t>Optimizes for CPU: work that has to actually run</a:t>
-            </a:r>
-          </a:p>
-          <a:p>
-            <a:r>
-              <a:rPr lang="en-US" dirty="0"/>
               <a:t>Limited by hardware resources</a:t>
             </a:r>
           </a:p>
           <a:p>
             <a:pPr lvl="2"/>
             <a:r>
-              <a:rPr lang="en-US" dirty="0"/>
+              <a:rPr lang="en-US" sz="2800" dirty="0"/>
               <a:t>`Environment.ProcessorCount`</a:t>
             </a:r>
           </a:p>
@@ -9582,7 +9593,7 @@
         <p:spPr>
           <a:xfrm>
             <a:off x="274320" y="1627632"/>
-            <a:ext cx="5303520" cy="2948499"/>
+            <a:ext cx="8782594" cy="2474524"/>
           </a:xfrm>
         </p:spPr>
         <p:txBody>
@@ -9606,11 +9617,6 @@
               <a:rPr lang="en-US" sz="2000" dirty="0"/>
               <a:t>Prevents each thread from blocking</a:t>
             </a:r>
-          </a:p>
-          <a:p>
-            <a:pPr marL="0" indent="0">
-              <a:buNone/>
-            </a:pPr>
             <a:endParaRPr lang="en-US" sz="2800" dirty="0">
               <a:solidFill>
                 <a:srgbClr val="FF0000"/>
@@ -9618,9 +9624,6 @@
             </a:endParaRPr>
           </a:p>
           <a:p>
-            <a:pPr marL="0" indent="0">
-              <a:buNone/>
-            </a:pPr>
             <a:r>
               <a:rPr lang="en-US" sz="2800" b="1" dirty="0">
                 <a:solidFill>
@@ -9630,7 +9633,11 @@
               <a:t>Warning</a:t>
             </a:r>
             <a:r>
-              <a:rPr lang="en-US" sz="2800" dirty="0"/>
+              <a:rPr lang="en-US" sz="2800" dirty="0">
+                <a:solidFill>
+                  <a:schemeClr val="tx1"/>
+                </a:solidFill>
+              </a:rPr>
               <a:t> </a:t>
             </a:r>
           </a:p>
@@ -9653,14 +9660,15 @@
         </p:nvPicPr>
         <p:blipFill>
           <a:blip r:embed="rId3"/>
+          <a:srcRect l="6547" t="16060" r="7474" b="14992"/>
           <a:stretch>
             <a:fillRect/>
           </a:stretch>
         </p:blipFill>
         <p:spPr>
           <a:xfrm>
-            <a:off x="5577839" y="2068865"/>
-            <a:ext cx="6583680" cy="3588948"/>
+            <a:off x="6218237" y="4102156"/>
+            <a:ext cx="5660571" cy="2474524"/>
           </a:xfrm>
           <a:prstGeom prst="rect">
             <a:avLst/>
@@ -9995,7 +10003,7 @@
         <p:spPr>
           <a:xfrm>
             <a:off x="274320" y="1627632"/>
-            <a:ext cx="5303520" cy="4636008"/>
+            <a:ext cx="5303520" cy="1908215"/>
           </a:xfrm>
         </p:spPr>
         <p:txBody>
@@ -10010,13 +10018,13 @@
           <a:p>
             <a:r>
               <a:rPr lang="en-US" sz="2800" dirty="0"/>
-              <a:t>`Increment`, `Decrement`, `Add`: `int` and `long`</a:t>
+              <a:t>`Increment`, `Decrement`, `Add`: `int` and `long` </a:t>
             </a:r>
           </a:p>
           <a:p>
             <a:r>
               <a:rPr lang="en-US" sz="2800" dirty="0"/>
-              <a:t>No `decimal` overload, so `decimal` needs a `Lock`</a:t>
+              <a:t>No `decimal` overload</a:t>
             </a:r>
           </a:p>
         </p:txBody>
@@ -11692,6 +11700,16 @@
 </file>
 
 <file path=customXml/item1.xml><?xml version="1.0" encoding="utf-8"?>
+<p:properties xmlns:p="http://schemas.microsoft.com/office/2006/metadata/properties" xmlns:xsi="http://www.w3.org/2001/XMLSchema-instance" xmlns:pc="http://schemas.microsoft.com/office/infopath/2007/PartnerControls">
+  <documentManagement>
+    <_ip_UnifiedCompliancePolicyUIAction xmlns="http://schemas.microsoft.com/sharepoint/v3" xsi:nil="true"/>
+    <MediaServiceKeyPoints xmlns="16dc66bd-df5a-4495-a5c9-5e296f49988a" xsi:nil="true"/>
+    <_ip_UnifiedCompliancePolicyProperties xmlns="http://schemas.microsoft.com/sharepoint/v3" xsi:nil="true"/>
+  </documentManagement>
+</p:properties>
+</file>
+
+<file path=customXml/item2.xml><?xml version="1.0" encoding="utf-8"?>
 <ct:contentTypeSchema xmlns:ct="http://schemas.microsoft.com/office/2006/metadata/contentType" xmlns:ma="http://schemas.microsoft.com/office/2006/metadata/properties/metaAttributes" ct:_="" ma:_="" ma:contentTypeName="Document" ma:contentTypeID="0x010100A33D2391BFF58241AEB203BD95DC1F89" ma:contentTypeVersion="16" ma:contentTypeDescription="Create a new document." ma:contentTypeScope="" ma:versionID="bd4b5e6fa70efd11586bd069caa6259f">
   <xsd:schema xmlns:xsd="http://www.w3.org/2001/XMLSchema" xmlns:xs="http://www.w3.org/2001/XMLSchema" xmlns:p="http://schemas.microsoft.com/office/2006/metadata/properties" xmlns:ns1="http://schemas.microsoft.com/sharepoint/v3" xmlns:ns2="16dc66bd-df5a-4495-a5c9-5e296f49988a" xmlns:ns3="12239fb0-26c0-4a37-b790-6c81fba9d0fc" targetNamespace="http://schemas.microsoft.com/office/2006/metadata/properties" ma:root="true" ma:fieldsID="1236f19879e555dfdef409a5be7c6d72" ns1:_="" ns2:_="" ns3:_="">
     <xsd:import namespace="http://schemas.microsoft.com/sharepoint/v3"/>
@@ -11937,16 +11955,6 @@
 </ct:contentTypeSchema>
 </file>
 
-<file path=customXml/item2.xml><?xml version="1.0" encoding="utf-8"?>
-<p:properties xmlns:p="http://schemas.microsoft.com/office/2006/metadata/properties" xmlns:xsi="http://www.w3.org/2001/XMLSchema-instance" xmlns:pc="http://schemas.microsoft.com/office/infopath/2007/PartnerControls">
-  <documentManagement>
-    <_ip_UnifiedCompliancePolicyUIAction xmlns="http://schemas.microsoft.com/sharepoint/v3" xsi:nil="true"/>
-    <MediaServiceKeyPoints xmlns="16dc66bd-df5a-4495-a5c9-5e296f49988a" xsi:nil="true"/>
-    <_ip_UnifiedCompliancePolicyProperties xmlns="http://schemas.microsoft.com/sharepoint/v3" xsi:nil="true"/>
-  </documentManagement>
-</p:properties>
-</file>
-
 <file path=customXml/item3.xml><?xml version="1.0" encoding="utf-8"?>
 <?mso-contentType ?>
 <FormTemplates xmlns="http://schemas.microsoft.com/sharepoint/v3/contenttype/forms">
@@ -11957,6 +11965,24 @@
 </file>
 
 <file path=customXml/itemProps1.xml><?xml version="1.0" encoding="utf-8"?>
+<ds:datastoreItem xmlns:ds="http://schemas.openxmlformats.org/officeDocument/2006/customXml" ds:itemID="{B59C5458-A72E-4627-9FFC-D350DCB4700F}">
+  <ds:schemaRefs>
+    <ds:schemaRef ds:uri="http://schemas.microsoft.com/office/2006/metadata/properties"/>
+    <ds:schemaRef ds:uri="http://schemas.openxmlformats.org/package/2006/metadata/core-properties"/>
+    <ds:schemaRef ds:uri="http://purl.org/dc/dcmitype/"/>
+    <ds:schemaRef ds:uri="http://schemas.microsoft.com/office/infopath/2007/PartnerControls"/>
+    <ds:schemaRef ds:uri="http://schemas.microsoft.com/sharepoint/v3"/>
+    <ds:schemaRef ds:uri="http://purl.org/dc/elements/1.1/"/>
+    <ds:schemaRef ds:uri="http://schemas.microsoft.com/office/2006/documentManagement/types"/>
+    <ds:schemaRef ds:uri="12239fb0-26c0-4a37-b790-6c81fba9d0fc"/>
+    <ds:schemaRef ds:uri="16dc66bd-df5a-4495-a5c9-5e296f49988a"/>
+    <ds:schemaRef ds:uri="http://www.w3.org/XML/1998/namespace"/>
+    <ds:schemaRef ds:uri="http://purl.org/dc/terms/"/>
+  </ds:schemaRefs>
+</ds:datastoreItem>
+</file>
+
+<file path=customXml/itemProps2.xml><?xml version="1.0" encoding="utf-8"?>
 <ds:datastoreItem xmlns:ds="http://schemas.openxmlformats.org/officeDocument/2006/customXml" ds:itemID="{F517AA3B-FC88-46DF-B5BA-DC6634CFCC94}">
   <ds:schemaRefs>
     <ds:schemaRef ds:uri="12239fb0-26c0-4a37-b790-6c81fba9d0fc"/>
@@ -11976,24 +12002,6 @@
 </ds:datastoreItem>
 </file>
 
-<file path=customXml/itemProps2.xml><?xml version="1.0" encoding="utf-8"?>
-<ds:datastoreItem xmlns:ds="http://schemas.openxmlformats.org/officeDocument/2006/customXml" ds:itemID="{B59C5458-A72E-4627-9FFC-D350DCB4700F}">
-  <ds:schemaRefs>
-    <ds:schemaRef ds:uri="http://schemas.microsoft.com/office/2006/metadata/properties"/>
-    <ds:schemaRef ds:uri="http://schemas.openxmlformats.org/package/2006/metadata/core-properties"/>
-    <ds:schemaRef ds:uri="http://purl.org/dc/dcmitype/"/>
-    <ds:schemaRef ds:uri="http://schemas.microsoft.com/office/infopath/2007/PartnerControls"/>
-    <ds:schemaRef ds:uri="http://schemas.microsoft.com/sharepoint/v3"/>
-    <ds:schemaRef ds:uri="http://purl.org/dc/elements/1.1/"/>
-    <ds:schemaRef ds:uri="http://schemas.microsoft.com/office/2006/documentManagement/types"/>
-    <ds:schemaRef ds:uri="12239fb0-26c0-4a37-b790-6c81fba9d0fc"/>
-    <ds:schemaRef ds:uri="16dc66bd-df5a-4495-a5c9-5e296f49988a"/>
-    <ds:schemaRef ds:uri="http://www.w3.org/XML/1998/namespace"/>
-    <ds:schemaRef ds:uri="http://purl.org/dc/terms/"/>
-  </ds:schemaRefs>
-</ds:datastoreItem>
-</file>
-
 <file path=customXml/itemProps3.xml><?xml version="1.0" encoding="utf-8"?>
 <ds:datastoreItem xmlns:ds="http://schemas.openxmlformats.org/officeDocument/2006/customXml" ds:itemID="{758FDAC0-319D-4A54-8D8E-1D42CB1F8004}">
   <ds:schemaRefs>

</xml_diff>